<commit_message>
innovatex-t2-aqi: lead re-verification of 10 fact rows; correct CAQM fine yardstick (₹1–2 lakh schedule, not ₹5 lakh) everywhere
</commit_message>
<xml_diff>
--- a/innovatex-t2-aqi/deliverables/zonal-deck.pptx
+++ b/innovatex-t2-aqi/deliverables/zonal-deck.pptx
@@ -1313,7 +1313,7 @@
             <a:r>
               <a:rPr lang="en-US" dirty="0"/>
               <a:t>TIME 1:10–2:00 (50 s).
-SAY: "Delhi measures air at city scale: forty-seven reference monitors, roughly one per twenty-five to fifty square kilometres. A monitor can tell you the air is bad; it can't tell you which of the sites around it made it bad. So compliance is a checklist — anti-smog guns, CCTV, self-audits — and fines are flat per violation, whatever the air. And when tankers are filmed spraying a reference monitor, people stop trusting the numbers."</a:t>
+SAY: "Delhi measures air at city scale: forty-seven reference monitors, roughly one per twenty-five to fifty square kilometres. A monitor can tell you the air is bad; it can't tell you which of the sites around it made it bad. So compliance is a checklist — anti-smog guns, CCTV, self-audits — and fines are set by site area, not by how much dust a site actually releases. And when tankers are filmed spraying a reference monitor, people stop trusting the numbers."</a:t>
             </a:r>
             <a:endParaRPr lang="en-US" dirty="0"/>
           </a:p>
@@ -1847,7 +1847,7 @@
             <a:r>
               <a:rPr lang="en-US" dirty="0"/>
               <a:t>TIME 7:00–7:50 (50 s).
-SAY: "Costs come from vendor listings we opened: about sixty-one thousand rupees of parts for a four-node ring, wind sensor, gateway and misting line. That's parts only — not installation or upkeep. The wind sensor is a quarter of it. Power comes from datasheets: about ten watt-hours a day per node, so a ten-watt panel covers about twice the load even in December, and the battery lasts about twelve days without sun. Compare that with one five-lakh fine."</a:t>
+SAY: "Costs come from vendor listings we opened: about sixty-one thousand rupees of parts for a four-node ring, wind sensor, gateway and misting line. That's parts only — not installation or upkeep. The wind sensor is a quarter of it. Power comes from datasheets: about ten watt-hours a day per node, so a ten-watt panel covers about twice the load even in December, and the battery lasts about twelve days without sun. Compare that with one violation: one to two lakh rupees under CAQM's schedule, doubled under GRAP."</a:t>
             </a:r>
             <a:endParaRPr lang="en-US" dirty="0"/>
           </a:p>

</xml_diff>

<commit_message>
innovatex-t2-aqi: offline demo (regulator ranking on simulated sites over a real Delhi week), backup slide B7, docs re-rendered
</commit_message>
<xml_diff>
--- a/innovatex-t2-aqi/deliverables/zonal-deck.pptx
+++ b/innovatex-t2-aqi/deliverables/zonal-deck.pptx
@@ -21,9 +21,10 @@
     <p:sldId id="269" r:id="rId15"/>
     <p:sldId id="270" r:id="rId16"/>
     <p:sldId id="271" r:id="rId17"/>
+    <p:sldId id="272" r:id="rId18"/>
   </p:sldIdLst>
   <p:notesMasterIdLst>
-    <p:notesMasterId r:id="rId18"/>
+    <p:notesMasterId r:id="rId19"/>
   </p:notesMasterIdLst>
   <p:sldSz cx="12192000" cy="6858000"/>
   <p:notesSz cx="6858000" cy="12192000"/>
@@ -517,7 +518,7 @@
           <a:p>
             <a:r>
               <a:rPr lang="en-US" dirty="0"/>
-              <a:t>TIME 0:00–0:20 (20 s). LOGISTICS: present zonal-deck.pdf from your own laptop; backup slides B1–B6 follow the last main slide. Cue card: presenter-card.pdf.
+              <a:t>TIME 0:00–0:20 (20 s). LOGISTICS: present zonal-deck.pdf from your own laptop, with demo/dustledger-demo.html pre-opened in a second tab (offline); backup slides B1–B7 follow the last main slide. Cue card: presenter-card.pdf.
 SAY: "We're ‹team›. Every winter Delhi stops every construction site, clean or dirty, because it can't tell them apart. We propose a way to measure each site's own dust. Today we have the data pipeline and a stress-tested simulation; the sensor ring is our Round-2 build."</a:t>
             </a:r>
             <a:endParaRPr lang="en-US" dirty="0"/>
@@ -1135,6 +1136,94 @@
           <a:p>
             <a:r>
               <a:rPr lang="en-US" dirty="0"/>
+              <a:t>BACKUP. If the demo tab fails, show this. Say: "Real background and wind; simulated sites. The list tells an inspector where to look first; the truth toggle shows where the ring is wrong — Site D and F swap places because both are near the noise floor."</a:t>
+            </a:r>
+            <a:endParaRPr lang="en-US" dirty="0"/>
+          </a:p>
+        </p:txBody>
+      </p:sp>
+      <p:sp>
+        <p:nvSpPr>
+          <p:cNvPr id="4" name="Slide Number Placeholder 3"/>
+          <p:cNvSpPr>
+            <a:spLocks noGrp="1"/>
+          </p:cNvSpPr>
+          <p:nvPr>
+            <p:ph type="sldNum" sz="quarter" idx="10"/>
+          </p:nvPr>
+        </p:nvSpPr>
+        <p:spPr/>
+        <p:txBody>
+          <a:bodyPr/>
+          <a:lstStyle/>
+          <a:p>
+            <a:fld id="{F7021451-1387-4CA6-816F-3879F97B5CBC}" type="slidenum">
+              <a:rPr lang="en-US"/>
+              <a:t>16</a:t>
+            </a:fld>
+            <a:endParaRPr lang="en-US"/>
+          </a:p>
+        </p:txBody>
+      </p:sp>
+    </p:spTree>
+    <p:extLst>
+      <p:ext uri="{BB962C8B-B14F-4D97-AF65-F5344CB8AC3E}">
+        <p14:creationId xmlns:p14="http://schemas.microsoft.com/office/powerpoint/2010/main" val="1024086991"/>
+      </p:ext>
+    </p:extLst>
+  </p:cSld>
+  <p:clrMapOvr>
+    <a:masterClrMapping/>
+  </p:clrMapOvr>
+</p:notes>
+</file>
+
+<file path=ppt/notesSlides/notesSlide17.xml><?xml version="1.0" encoding="utf-8"?>
+<p:notes xmlns:a="http://schemas.openxmlformats.org/drawingml/2006/main" xmlns:r="http://schemas.openxmlformats.org/officeDocument/2006/relationships" xmlns:p="http://schemas.openxmlformats.org/presentationml/2006/main">
+  <p:cSld>
+    <p:spTree>
+      <p:nvGrpSpPr>
+        <p:cNvPr id="1" name=""/>
+        <p:cNvGrpSpPr/>
+        <p:nvPr/>
+      </p:nvGrpSpPr>
+      <p:grpSpPr>
+        <a:xfrm>
+          <a:off x="0" y="0"/>
+          <a:ext cx="0" cy="0"/>
+          <a:chOff x="0" y="0"/>
+          <a:chExt cx="0" cy="0"/>
+        </a:xfrm>
+      </p:grpSpPr>
+      <p:sp>
+        <p:nvSpPr>
+          <p:cNvPr id="2" name="Slide Image Placeholder 1"/>
+          <p:cNvSpPr>
+            <a:spLocks noGrp="1" noRot="1" noChangeAspect="1"/>
+          </p:cNvSpPr>
+          <p:nvPr>
+            <p:ph type="sldImg"/>
+          </p:nvPr>
+        </p:nvSpPr>
+        <p:spPr/>
+      </p:sp>
+      <p:sp>
+        <p:nvSpPr>
+          <p:cNvPr id="3" name="Notes Placeholder 2"/>
+          <p:cNvSpPr>
+            <a:spLocks noGrp="1"/>
+          </p:cNvSpPr>
+          <p:nvPr>
+            <p:ph type="body" idx="1"/>
+          </p:nvPr>
+        </p:nvSpPr>
+        <p:spPr/>
+        <p:txBody>
+          <a:bodyPr/>
+          <a:lstStyle/>
+          <a:p>
+            <a:r>
+              <a:rPr lang="en-US" dirty="0"/>
               <a:t>BACKUP. Sources slide.</a:t>
             </a:r>
             <a:endParaRPr lang="en-US" dirty="0"/>
@@ -1158,7 +1247,7 @@
           <a:p>
             <a:fld id="{F7021451-1387-4CA6-816F-3879F97B5CBC}" type="slidenum">
               <a:rPr lang="en-US"/>
-              <a:t>16</a:t>
+              <a:t>17</a:t>
             </a:fld>
             <a:endParaRPr lang="en-US"/>
           </a:p>
@@ -2472,6 +2561,45 @@
 <file path=ppt/slides/slide16.xml><?xml version="1.0" encoding="utf-8"?>
 <p:sld xmlns:a="http://schemas.openxmlformats.org/drawingml/2006/main" xmlns:r="http://schemas.openxmlformats.org/officeDocument/2006/relationships" xmlns:p="http://schemas.openxmlformats.org/presentationml/2006/main">
   <p:cSld name="Slide 16">
+    <p:bg>
+      <p:bgPr>
+        <a:blipFill dpi="0" rotWithShape="1">
+          <a:blip r:embed="rId1">
+            <a:lum/>
+          </a:blip>
+          <a:srcRect/>
+          <a:stretch>
+            <a:fillRect/>
+          </a:stretch>
+        </a:blipFill>
+        <a:effectLst/>
+      </p:bgPr>
+    </p:bg>
+    <p:spTree>
+      <p:nvGrpSpPr>
+        <p:cNvPr id="1" name=""/>
+        <p:cNvGrpSpPr/>
+        <p:nvPr/>
+      </p:nvGrpSpPr>
+      <p:grpSpPr>
+        <a:xfrm>
+          <a:off x="0" y="0"/>
+          <a:ext cx="0" cy="0"/>
+          <a:chOff x="0" y="0"/>
+          <a:chExt cx="0" cy="0"/>
+        </a:xfrm>
+      </p:grpSpPr>
+    </p:spTree>
+  </p:cSld>
+  <p:clrMapOvr>
+    <a:masterClrMapping/>
+  </p:clrMapOvr>
+</p:sld>
+</file>
+
+<file path=ppt/slides/slide17.xml><?xml version="1.0" encoding="utf-8"?>
+<p:sld xmlns:a="http://schemas.openxmlformats.org/drawingml/2006/main" xmlns:r="http://schemas.openxmlformats.org/officeDocument/2006/relationships" xmlns:p="http://schemas.openxmlformats.org/presentationml/2006/main">
+  <p:cSld name="Slide 17">
     <p:bg>
       <p:bgPr>
         <a:blipFill dpi="0" rotWithShape="1">

</xml_diff>

<commit_message>
innovatex-t2-aqi: apply cross-model reviews (gpt-6-astra, gpt-6-sol) — honest work-hour/oracle/not-blind claims, refcal14 baseline, machine-written breakdown, hardened check_docs, ingest checks, final memo v3, lead response + ledger
</commit_message>
<xml_diff>
--- a/innovatex-t2-aqi/deliverables/zonal-deck.pptx
+++ b/innovatex-t2-aqi/deliverables/zonal-deck.pptx
@@ -518,8 +518,8 @@
           <a:p>
             <a:r>
               <a:rPr lang="en-US" dirty="0"/>
-              <a:t>TIME 0:00–0:20 (20 s). LOGISTICS: present zonal-deck.pdf from your own laptop, with demo/dustledger-demo.html pre-opened in a second tab (offline); backup slides B1–B7 follow the last main slide. Cue card: presenter-card.pdf.
-SAY: "We're ‹team›. Every winter Delhi stops every construction site, clean or dirty, because it can't tell them apart. We propose a way to measure each site's own dust. Today we have the data pipeline and a stress-tested simulation; the sensor ring is our Round-2 build."</a:t>
+              <a:t>TIME 0:00–0:20 (20 s). LOGISTICS: present zonal-deck.pdf from your own laptop, with demo/dustledger-demo.html pre-opened in a second tab (offline); backup slides B1–B8 follow the last main slide. Cue card: presenter-card.pdf.
+SAY: "We're ‹team›. Delhi's winter dust rules are applied by activity and by pollution stage, not by what each site actually releases. We propose a way to estimate each site's own dust. Today we have the data pipeline and a stress-tested simulation; the sensor ring is our Round-2 build."</a:t>
             </a:r>
             <a:endParaRPr lang="en-US" dirty="0"/>
           </a:p>
@@ -607,8 +607,7 @@
           <a:p>
             <a:r>
               <a:rPr lang="en-US" dirty="0"/>
-              <a:t>TIME 7:50–9:15 (85 s). Then stop: 45 s reserve.
-SAY: "Here's what we'll prove, and when. In October, four nodes side by side and, if we get a slot, next to a reference monitor. A real-site trial has to happen before November first, when Delhi's restrictions start, or at a site that's allowed to operate. Otherwise our evidence is a controlled dust-source trial on campus, with misting on and off, measuring the site's own dust, how often we abstain, and the water used. On the first of December: a working prototype with real sensor data. One proposal — not a promise: an earned-permission pilot for sites that prove they're clean. Our ask: a pilot site, a reference co-location slot, and a contact at DPCC or CAQM. Measure the site, not the city."</a:t>
+              <a:t>BACKUP. Use for "why not forecasting?". Say: with only months of station history, our ML did not beat yesterday's value for PM2.5 without peeking at tomorrow's actual weather, which no forecaster has. The ERA5 inputs are retrospective; an operational version would need issued forecasts. CAMS here is one grid point with an uncontrolled forecast vintage, so it's a reference, not a fair competitor. IITM already runs city forecasting.</a:t>
             </a:r>
             <a:endParaRPr lang="en-US" dirty="0"/>
           </a:p>
@@ -696,7 +695,7 @@
           <a:p>
             <a:r>
               <a:rPr lang="en-US" dirty="0"/>
-              <a:t>BACKUP. Use for "show me how it behaves". Top: real Delhi background PM10 at a DPCC monitor. Bottom: a simulated site's true contribution vs the fixed pair and DustLedger; gaps are 'inconclusive' hours. The clipped peak is a calm-wind hour in the simulation.</a:t>
+              <a:t>BACKUP. Use for "show me how it behaves". Top: real Delhi background PM10 at a DPCC monitor. Bottom: a simulated site's true contribution vs the fixed pair and DustLedger; gaps are 'inconclusive' hours, not zero pollution. The clipped peak is a calm-wind hour in the simulation.</a:t>
             </a:r>
             <a:endParaRPr lang="en-US" dirty="0"/>
           </a:p>
@@ -784,7 +783,7 @@
           <a:p>
             <a:r>
               <a:rPr lang="en-US" dirty="0"/>
-              <a:t>BACKUP. Use for "what have you actually built?" Answer: the data pipeline, the forecast benchmark and the stress-tested replay are real and reproducible; the site and sensors in the replay are simulated; the hardware is the Round-2 build.</a:t>
+              <a:t>BACKUP. Use for "what have you actually built?"</a:t>
             </a:r>
             <a:endParaRPr lang="en-US" dirty="0"/>
           </a:p>
@@ -872,7 +871,7 @@
           <a:p>
             <a:r>
               <a:rPr lang="en-US" dirty="0"/>
-              <a:t>BACKUP. Use for "what about Delhi's calm winter nights?" The replay abstains below 0.5 m/s (coverage 0.95); with a 1 m/s threshold, expect at least one winter hour in six to be inconclusive. Improving calm-wind handling is on the backlog, not a claim.</a:t>
+              <a:t>BACKUP. Use for "what about Delhi's calm winter nights?" The replay abstains below 0.5 m/s; coverage in the stress test is shown on slide 7. Better calm-wind handling is on the backlog, not a claim.</a:t>
             </a:r>
             <a:endParaRPr lang="en-US" dirty="0"/>
           </a:p>
@@ -960,7 +959,7 @@
           <a:p>
             <a:r>
               <a:rPr lang="en-US" dirty="0"/>
-              <a:t>BACKUP. Use for "isn't your simulator rigged?" Answer: an independent reviewer found v1 favoured our method; v2.1 adds those failure modes and a fair baseline (weekly reference visits). Self-calibration still wins in all four scenarios, by less. It remains a simulation until the dust test.</a:t>
+              <a:t>BACKUP. Use for "isn't your simulator rigged?" Answer: the first simulator favoured us and was rebuilt after review; a second reviewer added a stronger reference baseline; self-calibration still wins on all-hour error, but work-hour errors are large and this is not a blind test.</a:t>
             </a:r>
             <a:endParaRPr lang="en-US" dirty="0"/>
           </a:p>
@@ -1136,7 +1135,7 @@
           <a:p>
             <a:r>
               <a:rPr lang="en-US" dirty="0"/>
-              <a:t>BACKUP. If the demo tab fails, show this. Say: "Real background and wind; simulated sites. The list tells an inspector where to look first; the truth toggle shows where the ring is wrong — Site D and F swap places because both are near the noise floor."</a:t>
+              <a:t>BACKUP. If the demo tab fails, show this. Say: "Real background and wind; simulated sites. The list tells an inspector where to look first; the truth toggle shows where the ring is wrong — the two cleanest sites swap places because both are near the noise floor."</a:t>
             </a:r>
             <a:endParaRPr lang="en-US" dirty="0"/>
           </a:p>
@@ -1312,8 +1311,8 @@
           <a:p>
             <a:r>
               <a:rPr lang="en-US" dirty="0"/>
-              <a:t>TIME 0:20–1:10 (50 s).
-SAY: "Delhi's Winter Action Plan for this year prohibits dust-generating demolition and outdoor civil works from November first to January thirty-first, and bans all construction from December tenth to January twentieth. GRAP emergencies stop sites on top of that: last year GRAP-3 halted construction for sixteen days. Every site is treated the same, whatever it does about dust."</a:t>
+              <a:t>TIME 0:20–1:00 (40 s).
+SAY: "Delhi's Winter Action Plan for this year, as reported, prohibits dust-generating demolition and outdoor civil works from November first to January thirty-first, and bans construction from December tenth to January twentieth. GRAP emergencies add stage-wise stops; last year GRAP-3 halted construction for sixteen days. These rules follow the activity and the pollution stage — not what each site actually releases."</a:t>
             </a:r>
             <a:endParaRPr lang="en-US" dirty="0"/>
           </a:p>
@@ -1401,8 +1400,8 @@
           <a:p>
             <a:r>
               <a:rPr lang="en-US" dirty="0"/>
-              <a:t>TIME 1:10–2:00 (50 s).
-SAY: "Delhi measures air at city scale: forty-seven reference monitors, roughly one per twenty-five to fifty square kilometres. A monitor can tell you the air is bad; it can't tell you which of the sites around it made it bad. So compliance is a checklist — anti-smog guns, CCTV, self-audits — and fines are set by site area, not by how much dust a site actually releases. And when tankers are filmed spraying a reference monitor, people stop trusting the numbers."</a:t>
+              <a:t>TIME 1:00–1:45 (45 s).
+SAY: "Delhi measures air at city scale: forty-seven reference monitors, planned at about one per twenty-five to fifty square kilometres. A monitor can tell you the air is bad; it can't tell you which site around it made it bad. So compliance is a checklist — anti-smog guns, CCTV, self-audits — and fines depend on site area, not on how much dust a site releases. And when tankers are filmed spraying a reference monitor, people stop trusting the numbers."</a:t>
             </a:r>
             <a:endParaRPr lang="en-US" dirty="0"/>
           </a:p>
@@ -1490,8 +1489,8 @@
           <a:p>
             <a:r>
               <a:rPr lang="en-US" dirty="0"/>
-              <a:t>TIME 2:00–3:00 (60 s).
-SAY: "Here's the honest size of the problem. In IIT Kanpur's source study for the Delhi government, construction material was two to five per cent of ambient PM10. It's a real source, but a small one. Yet it gets the bluntest tool there is. The cost falls on workers: nearly fourteen lakh are on Delhi's welfare-board rolls but only about ninety thousand are active members, and in one survey most site workers weren't even registered for the aid. So we are not promising to clean Delhi's air. We're proposing to make enforcement on this source fair and targeted."</a:t>
+              <a:t>TIME 1:45–2:35 (50 s).
+SAY: "Here's the honest size of the problem. In IIT Kanpur's source study for the Delhi government, construction material was two to five per cent of ambient PM10. It's a real source, but a small one in that study. The stops fall hardest on daily-wage workers: nearly fourteen lakh are on Delhi's welfare-board rolls but only about ninety thousand are active members, and in one survey most site workers weren't registered for the aid. So we are not promising to clean Delhi's air. We're proposing an evidence tool for fairer, targeted inspection."</a:t>
             </a:r>
             <a:endParaRPr lang="en-US" dirty="0"/>
           </a:p>
@@ -1579,8 +1578,8 @@
           <a:p>
             <a:r>
               <a:rPr lang="en-US" dirty="0"/>
-              <a:t>TIME 3:00–3:50 (50 s).
-SAY: "Indian compliance monitors stream a PM number to the DPCC cloud. But in Delhi's winter, background PM10 averages around three hundred micrograms, so a sensor at the fence mostly measures Delhi, not the site. Anti-smog guns run on timers. Forecasts predict the city, not the site. Fence-line attribution exists — for mines and refineries — and we'd borrow it, but we didn't find it packaged for Indian construction sites at low cost."</a:t>
+              <a:t>TIME 2:35–3:15 (40 s).
+SAY: "Indian compliance monitors stream a PM number to the DPCC cloud. But Delhi's winter background is in the hundreds of micrograms, so a sensor at the fence mostly measures Delhi, not the site. Anti-smog guns run on timers. Forecasts predict the city, not the site. Fence-line attribution is established for mines and industry; we borrow it — we just didn't find it packaged for Indian construction sites at low cost."</a:t>
             </a:r>
             <a:endParaRPr lang="en-US" dirty="0"/>
           </a:p>
@@ -1668,8 +1667,8 @@
           <a:p>
             <a:r>
               <a:rPr lang="en-US" dirty="0"/>
-              <a:t>TIME 3:50–5:10 (80 s).
-SAY: "Four cheap sensors on the boundary and a wind sensor. Delhi's background reaches all four; the site's own dust reaches only the downwind ones. The difference is the site's contribution. When the wind is calm or swirling we say 'inconclusive' instead of guessing — and inconclusive never means clean. When the site is the cause, the misting line turns on; not on a timer. Records are signed on the device and hash-chained, so edits become detectable. The output is a ranking that tells inspectors where to look; penalties still need DPCC's own verification."</a:t>
+              <a:t>TIME 3:15–4:45 (90 s).
+SAY: "Four cheap sensors on the boundary and a wind sensor. Delhi's background reaches all four; the site's own dust reaches mostly the downwind ones. The difference is our estimate of the site's contribution — an inference, not proof of cause. When the wind is under half a metre per second, we say 'inconclusive', and inconclusive never means clean. A check for swirling wind and for nodes that disagree with the wind is planned, not built. When the estimate says the site is adding dust, the misting line turns on instead of running on a timer. Records are signed on the device and hash-chained, so edits become detectable. The output is a list that tells inspectors where to look first; penalties still need DPCC's own verification."</a:t>
             </a:r>
             <a:endParaRPr lang="en-US" dirty="0"/>
           </a:p>
@@ -1757,8 +1756,8 @@
           <a:p>
             <a:r>
               <a:rPr lang="en-US" dirty="0"/>
-              <a:t>TIME 5:10–5:50 (40 s).
-SAY: "Here's real data: four CPCB and DPCC monitors, two years, a strict time-ordered test. Yesterday's value predicts tomorrow's PM2.5 within about twenty-four micrograms. With one year of history, our gradient-boosting model added at most four per cent. IITM already runs city forecasting. So we use forecasts only to schedule dusty work, and put the innovation where nobody is: at the site."</a:t>
+              <a:t>TIME 4:45–6:15 (90 s).
+SAY: "This is the core test. The background PM and the wind are real Delhi data; the sites, their dust and the sensor faults are simulated. Two independent reviewers made it harder: sensor fouling, dust responding differently from ambient air, dirty nights, a neighbouring site, a biased wind vane, and a stronger baseline — a fourteen-day median of weekly reference visits. Across all hours, the fixed pair is off by about ninety-six micrograms, the ring by about sixty-nine, and the ring with self-calibration by about fifty-seven, against sixty-five for the reference baseline. But in work hours, when dust is actually emitted, self-calibration is no better than the reference baseline, and both errors roughly double. Its real gain is fewer false alarms — about half as many — which matters if a flag sends an inspector to a clean site. It's a simulation with fresh seeds, not a blind test; a controlled dust test decides."</a:t>
             </a:r>
             <a:endParaRPr lang="en-US" dirty="0"/>
           </a:p>
@@ -1846,8 +1845,8 @@
           <a:p>
             <a:r>
               <a:rPr lang="en-US" dirty="0"/>
-              <a:t>TIME 5:50–7:00 (70 s).
-SAY: "This is the core test. The background PM and the wind are real Delhi data; the site, its dust and the sensor faults are simulated. An independent reviewer made the simulator harder — sensor fouling, dust responding differently from ambient air, dirty nights, a neighbouring site, a biased wind vane — and we ran the held-out test once. A fixed upwind-downwind pair is off by about ninety-six micrograms; the wind-resolved ring by sixty-nine; adding self-calibration from the site's quiet hours, fifty-seven. That last step is seventeen per cent better than weekly reference visits — but it's simulation. A controlled dust test decides it. And in Delhi's winter, the wind is under one metre per second about one hour in six; there we say 'inconclusive'."</a:t>
+              <a:t>TIME 6:15–7:15 (60 s).
+SAY: "Costs come from vendor listings we opened: about sixty-one thousand rupees of parts for a four-node ring, a wind sensor, a gateway and a misting line. That's parts only — not installation or upkeep — and the wind sensor is a quarter of it. Power is a model estimate from datasheets: about ten watt-hours a day per node, so a ten-watt panel covers about twice the load in an average December, and the battery lasts about twelve days without sun. We'll bench-measure all of it. For scale, a single violation costs one to two lakh rupees under the 2024 schedule — but whether anyone will pay for this is untested."</a:t>
             </a:r>
             <a:endParaRPr lang="en-US" dirty="0"/>
           </a:p>
@@ -1935,8 +1934,8 @@
           <a:p>
             <a:r>
               <a:rPr lang="en-US" dirty="0"/>
-              <a:t>TIME 7:00–7:50 (50 s).
-SAY: "Costs come from vendor listings we opened: about sixty-one thousand rupees of parts for a four-node ring, wind sensor, gateway and misting line. That's parts only — not installation or upkeep. The wind sensor is a quarter of it. Power comes from datasheets: about ten watt-hours a day per node, so a ten-watt panel covers about twice the load even in December, and the battery lasts about twelve days without sun. Compare that with one violation: one to two lakh rupees under CAQM's schedule, doubled under GRAP."</a:t>
+              <a:t>TIME 7:15–8:45 (90 s). Then stop: 1:15 reserve.
+SAY: "Here's what we'll test, and every step depends on approvals. By mid-October, a bench-tested node, then four. In late October, four nodes side by side and, if we get a slot, next to a reference monitor. A real-site trial is only possible before November first, when Delhi's restrictions start, and only with a site and approvals in place. Otherwise our evidence is an approved, safety-controlled dust-source test with misting on and off in randomised blocks — measuring how well we recover a known source, how often we abstain, and the water used. We'll report that as a controlled test, never as field validation. One proposal — not a promise: an earned-permission pilot for sites that prove they're clean. Our ask: a pilot site, a reference co-location slot, and a DPCC or CAQM contact."</a:t>
             </a:r>
             <a:endParaRPr lang="en-US" dirty="0"/>
           </a:p>

</xml_diff>